<commit_message>
slides: add Dy10 force-malate slide to met variants PPT
New slide shows nan/raw/drop × 4 classifiers at Dy10 with MalateGlo forced in,
revealing where the floor correction actually fires and its small effect (~0.01 BA).
Observations updated to explain the conditional-metabolite/floor interaction.
Also adds force_malate param to _features_for_day_all and --force-malate flag
to met_classifier_comparison.

Co-Authored-By: Claude Sonnet 4.6 <noreply@anthropic.com>
</commit_message>
<xml_diff>
--- a/figures/met_variants_analysis.pptx
+++ b/figures/met_variants_analysis.pptx
@@ -12,6 +12,7 @@
     <p:sldId id="260" r:id="rId11"/>
     <p:sldId id="261" r:id="rId12"/>
     <p:sldId id="262" r:id="rId13"/>
+    <p:sldId id="263" r:id="rId14"/>
   </p:sldIdLst>
   <p:sldSz cx="12188952" cy="6858000" type="screen4x3"/>
   <p:notesSz cx="6858000" cy="9144000"/>
@@ -3649,6 +3650,127 @@
           <a:p>
             <a:pPr algn="l"/>
             <a:r>
+              <a:rPr sz="2200" b="1">
+                <a:solidFill>
+                  <a:srgbClr val="1F3864"/>
+                </a:solidFill>
+              </a:rPr>
+              <a:t>Dy10 Experiment: Forcing MalateGlo In Where Outliers Live</a:t>
+            </a:r>
+          </a:p>
+        </p:txBody>
+      </p:sp>
+      <p:pic>
+        <p:nvPicPr>
+          <p:cNvPr id="3" name="Picture 2" descr="image.png"/>
+          <p:cNvPicPr>
+            <a:picLocks noChangeAspect="1"/>
+          </p:cNvPicPr>
+          <p:nvPr/>
+        </p:nvPicPr>
+        <p:blipFill>
+          <a:blip r:embed="rId2"/>
+          <a:stretch>
+            <a:fillRect/>
+          </a:stretch>
+        </p:blipFill>
+        <p:spPr>
+          <a:xfrm>
+            <a:off x="320040" y="658368"/>
+            <a:ext cx="7498079" cy="3339778"/>
+          </a:xfrm>
+          <a:prstGeom prst="rect">
+            <a:avLst/>
+          </a:prstGeom>
+        </p:spPr>
+      </p:pic>
+      <p:sp>
+        <p:nvSpPr>
+          <p:cNvPr id="4" name="TextBox 3"/>
+          <p:cNvSpPr txBox="1"/>
+          <p:nvPr/>
+        </p:nvSpPr>
+        <p:spPr>
+          <a:xfrm>
+            <a:off x="7955279" y="658368"/>
+            <a:ext cx="3931920" cy="5760720"/>
+          </a:xfrm>
+          <a:prstGeom prst="rect">
+            <a:avLst/>
+          </a:prstGeom>
+          <a:noFill/>
+        </p:spPr>
+        <p:txBody>
+          <a:bodyPr wrap="square">
+            <a:spAutoFit/>
+          </a:bodyPr>
+          <a:lstStyle/>
+          <a:p>
+            <a:pPr algn="l"/>
+            <a:r>
+              <a:rPr sz="1100" b="0">
+                <a:solidFill>
+                  <a:srgbClr val="000000"/>
+                </a:solidFill>
+              </a:rPr>
+              <a:t>Why this experiment?
+  Extreme MalateGlo values (e.g. −5662 µM) exist only at Dy10.
+  MalateGlo is normally excluded for days ≤ Dy10 (conditional metabolite),
+  so the floor correction never fires in the standard pipeline.
+  Here we force MalateGlo into Dy10 features to test the correction directly.
+Key findings
+  • nan vs raw: ~0.006–0.011 BA difference — floor correction works but
+    the effect is tiny, within repeat noise (±0.03–0.05 SD).
+  • LogReg: nan=0.613 &gt; drop/baseline=0.548 — gains most from keeping
+    MalateGlo (even with outliers replaced by NaN).
+  • LGBM/MLP: nan ≈ raw ≈ drop ≈ baseline — insensitive to MalateGlo at Dy10.
+  • SVM: stuck at 0.500 regardless — features not separable at Dy10.</a:t>
+            </a:r>
+          </a:p>
+        </p:txBody>
+      </p:sp>
+    </p:spTree>
+  </p:cSld>
+  <p:clrMapOvr>
+    <a:masterClrMapping/>
+  </p:clrMapOvr>
+</p:sld>
+</file>
+
+<file path=ppt/slides/slide8.xml><?xml version="1.0" encoding="utf-8"?>
+<p:sld xmlns:a="http://schemas.openxmlformats.org/drawingml/2006/main" xmlns:p="http://schemas.openxmlformats.org/presentationml/2006/main" xmlns:r="http://schemas.openxmlformats.org/officeDocument/2006/relationships">
+  <p:cSld>
+    <p:spTree>
+      <p:nvGrpSpPr>
+        <p:cNvPr id="1" name=""/>
+        <p:cNvGrpSpPr/>
+        <p:nvPr/>
+      </p:nvGrpSpPr>
+      <p:grpSpPr/>
+      <p:sp>
+        <p:nvSpPr>
+          <p:cNvPr id="2" name="TextBox 1"/>
+          <p:cNvSpPr txBox="1"/>
+          <p:nvPr/>
+        </p:nvSpPr>
+        <p:spPr>
+          <a:xfrm>
+            <a:off x="320040" y="320040"/>
+            <a:ext cx="11430000" cy="502920"/>
+          </a:xfrm>
+          <a:prstGeom prst="rect">
+            <a:avLst/>
+          </a:prstGeom>
+          <a:noFill/>
+        </p:spPr>
+        <p:txBody>
+          <a:bodyPr wrap="square">
+            <a:spAutoFit/>
+          </a:bodyPr>
+          <a:lstStyle/>
+          <a:p>
+            <a:pPr algn="l"/>
+            <a:r>
               <a:rPr sz="2400" b="1">
                 <a:solidFill>
                   <a:srgbClr val="1F3864"/>
@@ -3689,9 +3811,11 @@
                 </a:solidFill>
               </a:rPr>
               <a:t>1. Floor correction (met_nan) vs raw values (met_raw)
-   Max |BA difference| across all days = 0.0000 — effectively zero.
-   → The −500 µM floor correction has no impact. Extreme outliers are absent
-     or already NaN for other reasons in this cohort.
+   Max |BA difference| across all days = 0.0000 — exactly zero.
+   → Root cause: extreme MalateGlo values (e.g. −5662 µM) exist only at Dy10,
+     but MalateGlo is a conditional feature excluded for days ≤ Dy10.
+     At Dy13+, where MalateGlo IS used, all values are &gt; −500 µM — floor never fires.
+   → Confirmed by Dy10 forced-inclusion experiment (see next slide).
 2. Dropping MalateGlo (met_no_malate) reduces BA at late days:
    Dy20_5 (+0.021), Dy28 (+0.016)
    → MalateGlo contributes signal at late time points where malate

</xml_diff>